<commit_message>
Compress embedded images to shrink file for GitHub's pptx preview
Co-Authored-By: Claude Sonnet 5 <noreply@anthropic.com>
</commit_message>
<xml_diff>
--- a/thesis_defense_presentation.pptx
+++ b/thesis_defense_presentation.pptx
@@ -3343,8 +3343,8 @@
         </p:blipFill>
         <p:spPr>
           <a:xfrm>
-            <a:off x="6035040" y="2408036"/>
-            <a:ext cx="5577840" cy="1859047"/>
+            <a:off x="6035040" y="2409779"/>
+            <a:ext cx="5577840" cy="1855561"/>
           </a:xfrm>
           <a:prstGeom prst="rect">
             <a:avLst/>
@@ -3593,8 +3593,8 @@
         </p:blipFill>
         <p:spPr>
           <a:xfrm>
-            <a:off x="1408293" y="3657600"/>
-            <a:ext cx="3675654" cy="2926080"/>
+            <a:off x="1407745" y="3657600"/>
+            <a:ext cx="3676749" cy="2926080"/>
           </a:xfrm>
           <a:prstGeom prst="rect">
             <a:avLst/>
@@ -3617,8 +3617,8 @@
         </p:blipFill>
         <p:spPr>
           <a:xfrm>
-            <a:off x="6986133" y="3657600"/>
-            <a:ext cx="3675654" cy="2926080"/>
+            <a:off x="6985585" y="3657600"/>
+            <a:ext cx="3676749" cy="2926080"/>
           </a:xfrm>
           <a:prstGeom prst="rect">
             <a:avLst/>
@@ -6032,7 +6032,7 @@
       </p:sp>
       <p:pic>
         <p:nvPicPr>
-          <p:cNvPr id="3" name="Picture 2" descr="paper_first_page.png"/>
+          <p:cNvPr id="3" name="Picture 2" descr="paper_first_page.jpg"/>
           <p:cNvPicPr>
             <a:picLocks noChangeAspect="1"/>
           </p:cNvPicPr>
@@ -6046,8 +6046,8 @@
         </p:blipFill>
         <p:spPr>
           <a:xfrm>
-            <a:off x="3925685" y="1005840"/>
-            <a:ext cx="4310149" cy="5577840"/>
+            <a:off x="3925233" y="1005840"/>
+            <a:ext cx="4311053" cy="5577840"/>
           </a:xfrm>
           <a:prstGeom prst="rect">
             <a:avLst/>
@@ -7003,8 +7003,8 @@
         </p:blipFill>
         <p:spPr>
           <a:xfrm>
-            <a:off x="6675120" y="2030256"/>
-            <a:ext cx="4937760" cy="2797487"/>
+            <a:off x="6675120" y="2030556"/>
+            <a:ext cx="4937760" cy="2796888"/>
           </a:xfrm>
           <a:prstGeom prst="rect">
             <a:avLst/>
@@ -7065,7 +7065,7 @@
       </p:sp>
       <p:pic>
         <p:nvPicPr>
-          <p:cNvPr id="3" name="Picture 2" descr="dataset_map.png"/>
+          <p:cNvPr id="3" name="Picture 2" descr="dataset_map.jpg"/>
           <p:cNvPicPr>
             <a:picLocks noChangeAspect="1"/>
           </p:cNvPicPr>
@@ -7079,8 +7079,8 @@
         </p:blipFill>
         <p:spPr>
           <a:xfrm>
-            <a:off x="1019783" y="1188720"/>
-            <a:ext cx="10121953" cy="5212080"/>
+            <a:off x="1016018" y="1188720"/>
+            <a:ext cx="10129484" cy="5212080"/>
           </a:xfrm>
           <a:prstGeom prst="rect">
             <a:avLst/>
@@ -7905,7 +7905,7 @@
       </p:sp>
       <p:pic>
         <p:nvPicPr>
-          <p:cNvPr id="3" name="Picture 2" descr="dqn_diagram.png"/>
+          <p:cNvPr id="3" name="Picture 2" descr="dqn_diagram.jpg"/>
           <p:cNvPicPr>
             <a:picLocks noChangeAspect="1"/>
           </p:cNvPicPr>

</xml_diff>